<commit_message>
Add barcode out and receiving workflows
</commit_message>
<xml_diff>
--- a/docs/customer-proposal.pptx
+++ b/docs/customer-proposal.pptx
@@ -3436,7 +3436,7 @@
                 <a:ea typeface="Yu Gothic UI" pitchFamily="34" charset="-122"/>
                 <a:cs typeface="Yu Gothic UI" pitchFamily="34" charset="-120"/>
               </a:rPr>
-              <a:t>JANで商品を素早く特定。担当者バーコードで「誰が」を自動記録。</a:t>
+              <a:t>JANで商品を素早く特定。作業スタッフを選択し、担当者を記録。</a:t>
             </a:r>
             <a:endParaRPr lang="en-US" sz="1150" dirty="0"/>
           </a:p>
@@ -4777,7 +4777,7 @@
                 <a:ea typeface="Yu Gothic UI" pitchFamily="34" charset="-122"/>
                 <a:cs typeface="Yu Gothic UI" pitchFamily="34" charset="-120"/>
               </a:rPr>
-              <a:t>ユーザー管理と操作ログで、誰が何をしたか追跡可能</a:t>
+              <a:t>ログインアカウント管理と操作ログで、誰が何をしたか追跡可能</a:t>
             </a:r>
             <a:endParaRPr lang="en-US" sz="1050" dirty="0"/>
           </a:p>
@@ -5530,7 +5530,7 @@
                 <a:ea typeface="Yu Gothic UI" pitchFamily="34" charset="-122"/>
                 <a:cs typeface="Yu Gothic UI" pitchFamily="34" charset="-120"/>
               </a:rPr>
-              <a:t>料金イメージ (5院規模目安)</a:t>
+              <a:t>料金イメージ</a:t>
             </a:r>
             <a:endParaRPr lang="en-US" sz="1400" dirty="0"/>
           </a:p>
@@ -5569,7 +5569,7 @@
                 <a:ea typeface="Yu Gothic UI" pitchFamily="34" charset="-122"/>
                 <a:cs typeface="Yu Gothic UI" pitchFamily="34" charset="-120"/>
               </a:rPr>
-              <a:t>初期導入費</a:t>
+              <a:t>基本料金</a:t>
             </a:r>
             <a:endParaRPr lang="en-US" sz="1200" dirty="0"/>
           </a:p>
@@ -5608,7 +5608,7 @@
                 <a:ea typeface="Yu Gothic UI" pitchFamily="34" charset="-122"/>
                 <a:cs typeface="Yu Gothic UI" pitchFamily="34" charset="-120"/>
               </a:rPr>
-              <a:t>20〜30万円</a:t>
+              <a:t>3万円/月</a:t>
             </a:r>
             <a:endParaRPr lang="en-US" sz="2000" dirty="0"/>
           </a:p>
@@ -5647,7 +5647,7 @@
                 <a:ea typeface="Yu Gothic UI" pitchFamily="34" charset="-122"/>
                 <a:cs typeface="Yu Gothic UI" pitchFamily="34" charset="-120"/>
               </a:rPr>
-              <a:t>月額利用料</a:t>
+              <a:t>追加クリニック</a:t>
             </a:r>
             <a:endParaRPr lang="en-US" sz="1200" dirty="0"/>
           </a:p>
@@ -5686,7 +5686,7 @@
                 <a:ea typeface="Yu Gothic UI" pitchFamily="34" charset="-122"/>
                 <a:cs typeface="Yu Gothic UI" pitchFamily="34" charset="-120"/>
               </a:rPr>
-              <a:t>3〜5万円</a:t>
+              <a:t>+1万円/月・1院ごと</a:t>
             </a:r>
             <a:endParaRPr lang="en-US" sz="2000" dirty="0"/>
           </a:p>
@@ -5748,7 +5748,7 @@
                 <a:ea typeface="Yu Gothic UI" pitchFamily="34" charset="-122"/>
                 <a:cs typeface="Yu Gothic UI" pitchFamily="34" charset="-120"/>
               </a:rPr>
-              <a:t>正式見積ではありません。データ量、写真保存、サポート範囲、SLA等で調整。</a:t>
+              <a:t>1院3万円/月、5院7万円/月。正式見積ではありません。データ量、写真保存、サポート範囲、SLA等で調整。</a:t>
             </a:r>
             <a:endParaRPr lang="en-US" sz="1000" dirty="0"/>
           </a:p>

</xml_diff>